<commit_message>
Updates for S3 DA-V8
</commit_message>
<xml_diff>
--- a/02-da-v8-insights-negocio/06-da-s2-inisights-negocio.pptx
+++ b/02-da-v8-insights-negocio/06-da-s2-inisights-negocio.pptx
@@ -984,7 +984,7 @@
                 <a:tab algn="l" pos="0"/>
               </a:tabLst>
             </a:pPr>
-            <a:fld id="{5DBE07BF-5DC0-4DF0-A90E-8A425CE6ADD0}" type="slidenum">
+            <a:fld id="{2E91F697-5733-4D4E-ACC0-E32A0482FAEC}" type="slidenum">
               <a:rPr b="0" lang="en" sz="1000" strike="noStrike" u="none">
                 <a:solidFill>
                   <a:schemeClr val="dk2"/>
@@ -1093,7 +1093,7 @@
                 <a:tab algn="l" pos="0"/>
               </a:tabLst>
             </a:pPr>
-            <a:fld id="{017539F6-AD49-4235-ABD6-3B8ED4C58A68}" type="slidenum">
+            <a:fld id="{547DE8E0-46A4-4D48-AE6A-19322CDC3DC6}" type="slidenum">
               <a:rPr b="0" lang="en" sz="1000" strike="noStrike" u="none">
                 <a:solidFill>
                   <a:schemeClr val="dk2"/>
@@ -2083,7 +2083,7 @@
                 <a:tab algn="l" pos="0"/>
               </a:tabLst>
             </a:pPr>
-            <a:fld id="{17531643-53FD-4FEE-B005-9196BFB8C03E}" type="slidenum">
+            <a:fld id="{0EE80CDC-9C5B-406E-ABAC-939CCCD90FEE}" type="slidenum">
               <a:rPr b="0" lang="en" sz="1000" strike="noStrike" u="none">
                 <a:solidFill>
                   <a:schemeClr val="dk2"/>
@@ -3073,7 +3073,7 @@
                 <a:tab algn="l" pos="0"/>
               </a:tabLst>
             </a:pPr>
-            <a:fld id="{31A9C773-059D-4C1F-9600-76F2611B5E26}" type="slidenum">
+            <a:fld id="{E2119DB2-4A83-428F-BB4F-E3464133A7A8}" type="slidenum">
               <a:rPr b="0" lang="en" sz="1000" strike="noStrike" u="none">
                 <a:solidFill>
                   <a:schemeClr val="dk2"/>
@@ -4063,7 +4063,7 @@
                 <a:tab algn="l" pos="0"/>
               </a:tabLst>
             </a:pPr>
-            <a:fld id="{E488A90B-DC0B-4746-84BF-BE678AE20616}" type="slidenum">
+            <a:fld id="{767B6483-B570-4AFE-8931-52C613E7A9AD}" type="slidenum">
               <a:rPr b="0" lang="en" sz="1000" strike="noStrike" u="none">
                 <a:solidFill>
                   <a:schemeClr val="dk2"/>
@@ -4779,7 +4779,7 @@
                 <a:tab algn="l" pos="0"/>
               </a:tabLst>
             </a:pPr>
-            <a:fld id="{B9A1FEE1-6BEF-4807-8C6C-52573027099F}" type="slidenum">
+            <a:fld id="{E8EE89BC-2FF1-4B64-898B-255EC18C0D18}" type="slidenum">
               <a:rPr b="0" lang="en" sz="1000" strike="noStrike" u="none">
                 <a:solidFill>
                   <a:schemeClr val="dk2"/>
@@ -6043,7 +6043,7 @@
                 <a:tab algn="l" pos="0"/>
               </a:tabLst>
             </a:pPr>
-            <a:fld id="{7C4A16D1-77A3-4506-8EB3-AC73F5636C4D}" type="slidenum">
+            <a:fld id="{1B2D80E0-7834-4884-8CA5-EB4C84DAD22B}" type="slidenum">
               <a:rPr b="0" lang="en" sz="1000" strike="noStrike" u="none">
                 <a:solidFill>
                   <a:schemeClr val="dk2"/>
@@ -7855,7 +7855,7 @@
                 <a:tab algn="l" pos="0"/>
               </a:tabLst>
             </a:pPr>
-            <a:fld id="{B4F0C496-E5D9-44DD-8E00-E2A4068B1C68}" type="slidenum">
+            <a:fld id="{A1FBF975-20E9-40B7-9390-3001F1F04D7B}" type="slidenum">
               <a:rPr b="0" lang="en" sz="1000" strike="noStrike" u="none">
                 <a:solidFill>
                   <a:schemeClr val="dk2"/>
@@ -7964,7 +7964,7 @@
                 <a:tab algn="l" pos="0"/>
               </a:tabLst>
             </a:pPr>
-            <a:fld id="{AE5DBC73-BFA0-439C-91C2-DAEF22F6B339}" type="slidenum">
+            <a:fld id="{FEBADBE1-1E08-445D-BAEA-2B14959E2D61}" type="slidenum">
               <a:rPr b="0" lang="en" sz="1000" strike="noStrike" u="none">
                 <a:solidFill>
                   <a:schemeClr val="dk2"/>
@@ -8465,7 +8465,7 @@
                 <a:tab algn="l" pos="0"/>
               </a:tabLst>
             </a:pPr>
-            <a:fld id="{23275663-0ABC-4AD4-951E-7D48A0EA509F}" type="slidenum">
+            <a:fld id="{FB0D6DA7-97B2-4424-88FF-126700CBB0C6}" type="slidenum">
               <a:rPr b="0" lang="en" sz="1000" strike="noStrike" u="none">
                 <a:solidFill>
                   <a:schemeClr val="dk2"/>
@@ -8907,7 +8907,7 @@
                 <a:tab algn="l" pos="0"/>
               </a:tabLst>
             </a:pPr>
-            <a:fld id="{BDBDE882-94CF-4419-9F8B-BDA638C161B5}" type="slidenum">
+            <a:fld id="{30E95D4E-E8A9-4A37-834F-69E89BF2707A}" type="slidenum">
               <a:rPr b="0" lang="en" sz="1000" strike="noStrike" u="none">
                 <a:solidFill>
                   <a:schemeClr val="dk2"/>
@@ -9623,7 +9623,7 @@
                 <a:tab algn="l" pos="0"/>
               </a:tabLst>
             </a:pPr>
-            <a:fld id="{8C8CD5D7-4512-44F7-9E53-B0344AB47495}" type="slidenum">
+            <a:fld id="{6AE6F3F5-2414-4299-9F72-A59A41B5FEAF}" type="slidenum">
               <a:rPr b="0" lang="en" sz="1000" strike="noStrike" u="none">
                 <a:solidFill>
                   <a:schemeClr val="dk2"/>
@@ -10339,7 +10339,7 @@
                 <a:tab algn="l" pos="0"/>
               </a:tabLst>
             </a:pPr>
-            <a:fld id="{D7C76FEF-42ED-4645-AAD5-65246645E49A}" type="slidenum">
+            <a:fld id="{F9BD37BD-FF80-4DFF-B861-10C1BC1AEAE5}" type="slidenum">
               <a:rPr b="0" lang="en" sz="1000" strike="noStrike" u="none">
                 <a:solidFill>
                   <a:schemeClr val="dk2"/>
@@ -10507,7 +10507,7 @@
                 <a:tab algn="l" pos="0"/>
               </a:tabLst>
             </a:pPr>
-            <a:fld id="{DA128E3F-DC12-4954-95D0-A635818C7D19}" type="slidenum">
+            <a:fld id="{28089C52-C2EF-4F26-A768-0123A874C04E}" type="slidenum">
               <a:rPr b="0" lang="en" sz="1000" strike="noStrike" u="none">
                 <a:solidFill>
                   <a:schemeClr val="dk2"/>
@@ -10616,7 +10616,7 @@
                 <a:tab algn="l" pos="0"/>
               </a:tabLst>
             </a:pPr>
-            <a:fld id="{5EEE62FD-5E2C-4EC2-B6D6-FBFB991B5C1A}" type="slidenum">
+            <a:fld id="{6861800A-0B02-48E1-B1CD-CC45BC368A80}" type="slidenum">
               <a:rPr b="0" lang="en" sz="1000" strike="noStrike" u="none">
                 <a:solidFill>
                   <a:schemeClr val="dk2"/>
@@ -11606,7 +11606,7 @@
                 <a:tab algn="l" pos="0"/>
               </a:tabLst>
             </a:pPr>
-            <a:fld id="{46811FF1-9801-4DF7-AA6C-9D765A6AC488}" type="slidenum">
+            <a:fld id="{EB3EBAE5-0F53-4A35-A48D-AFEA4CC2061F}" type="slidenum">
               <a:rPr b="0" lang="en" sz="1000" strike="noStrike" u="none">
                 <a:solidFill>
                   <a:schemeClr val="dk2"/>
@@ -12596,7 +12596,7 @@
                 <a:tab algn="l" pos="0"/>
               </a:tabLst>
             </a:pPr>
-            <a:fld id="{7B892CD0-E73D-47C7-8E8E-2EC6B42021F4}" type="slidenum">
+            <a:fld id="{C2D66D37-95D1-4B22-B737-76CC06EAF0E8}" type="slidenum">
               <a:rPr b="0" lang="en" sz="1000" strike="noStrike" u="none">
                 <a:solidFill>
                   <a:schemeClr val="dk2"/>
@@ -12655,7 +12655,7 @@
         <p:txBody>
           <a:bodyPr/>
           <a:p>
-            <a:fld id="{EA3BD559-3ABC-4781-BFDB-751C9F13EFE7}" type="slidenum">
+            <a:fld id="{4D7FD32A-5C43-44C7-BD27-27F5B6A187B5}" type="slidenum">
               <a:t>&lt;#&gt;</a:t>
             </a:fld>
           </a:p>
@@ -12697,7 +12697,7 @@
         <p:txBody>
           <a:bodyPr/>
           <a:p>
-            <a:fld id="{5569DA2E-16D3-4CE9-9DF0-C9C90AA7BCF9}" type="slidenum">
+            <a:fld id="{E2E5010E-7BE8-42D5-B276-5B654D6086EC}" type="slidenum">
               <a:t>&lt;#&gt;</a:t>
             </a:fld>
           </a:p>
@@ -13944,7 +13944,7 @@
                 <a:tab algn="l" pos="0"/>
               </a:tabLst>
             </a:pPr>
-            <a:fld id="{78F64F21-9D0B-4BB1-AE2D-C049B5C207D6}" type="slidenum">
+            <a:fld id="{450C2F78-9B59-4CEE-B79D-86FE3FE99B36}" type="slidenum">
               <a:rPr b="0" lang="en" sz="1000" strike="noStrike" u="none">
                 <a:solidFill>
                   <a:schemeClr val="dk2"/>
@@ -15756,7 +15756,7 @@
                 <a:tab algn="l" pos="0"/>
               </a:tabLst>
             </a:pPr>
-            <a:fld id="{68309446-1624-4E29-A889-4D137688D72F}" type="slidenum">
+            <a:fld id="{DA03CBEA-FFEA-4F0D-A17E-05EA0C7C5B1D}" type="slidenum">
               <a:rPr b="0" lang="en" sz="1000" strike="noStrike" u="none">
                 <a:solidFill>
                   <a:schemeClr val="dk2"/>
@@ -15865,7 +15865,7 @@
                 <a:tab algn="l" pos="0"/>
               </a:tabLst>
             </a:pPr>
-            <a:fld id="{96B160D5-5105-475D-B56D-3F117D590148}" type="slidenum">
+            <a:fld id="{E20D3A24-6B59-4963-801F-15D7978C647A}" type="slidenum">
               <a:rPr b="0" lang="en" sz="1000" strike="noStrike" u="none">
                 <a:solidFill>
                   <a:schemeClr val="dk2"/>
@@ -16366,7 +16366,7 @@
                 <a:tab algn="l" pos="0"/>
               </a:tabLst>
             </a:pPr>
-            <a:fld id="{EC8E552B-06BF-4AF9-AD9C-BB9AD7C1E528}" type="slidenum">
+            <a:fld id="{75BC53C2-1952-4599-ABAC-B6554DB4BB6D}" type="slidenum">
               <a:rPr b="0" lang="en" sz="1000" strike="noStrike" u="none">
                 <a:solidFill>
                   <a:schemeClr val="dk2"/>
@@ -16808,7 +16808,7 @@
                 <a:tab algn="l" pos="0"/>
               </a:tabLst>
             </a:pPr>
-            <a:fld id="{8DC9964C-70F8-47C7-B900-ABFB79401BDF}" type="slidenum">
+            <a:fld id="{1D24483D-313C-498D-8368-25587B7E5497}" type="slidenum">
               <a:rPr b="0" lang="en" sz="1000" strike="noStrike" u="none">
                 <a:solidFill>
                   <a:schemeClr val="dk2"/>
@@ -17524,7 +17524,7 @@
                 <a:tab algn="l" pos="0"/>
               </a:tabLst>
             </a:pPr>
-            <a:fld id="{614D2879-8786-4B16-896A-236B586D3D56}" type="slidenum">
+            <a:fld id="{146E447E-18B9-4E3A-AA60-49162B10A2C3}" type="slidenum">
               <a:rPr b="0" lang="en" sz="1000" strike="noStrike" u="none">
                 <a:solidFill>
                   <a:schemeClr val="dk2"/>
@@ -17692,7 +17692,7 @@
                 <a:tab algn="l" pos="0"/>
               </a:tabLst>
             </a:pPr>
-            <a:fld id="{B6D8F5AC-20E3-44E3-9683-4558070FE169}" type="slidenum">
+            <a:fld id="{1F3D107B-CFA5-4C07-A653-E04E109227F8}" type="slidenum">
               <a:rPr b="0" lang="en" sz="1000" strike="noStrike" u="none">
                 <a:solidFill>
                   <a:schemeClr val="dk2"/>
@@ -17875,7 +17875,7 @@
                 <a:tab algn="l" pos="0"/>
               </a:tabLst>
             </a:pPr>
-            <a:fld id="{470F0AB0-4872-4392-90A1-8F8576DC5B9B}" type="slidenum">
+            <a:fld id="{D1C015EC-C7F5-4B46-B215-934198821CE4}" type="slidenum">
               <a:rPr b="0" lang="en" sz="1000" strike="noStrike" u="none">
                 <a:solidFill>
                   <a:schemeClr val="dk2"/>
@@ -18294,7 +18294,7 @@
                 <a:tab algn="l" pos="0"/>
               </a:tabLst>
             </a:pPr>
-            <a:fld id="{A589D05B-EA9E-4043-A566-5024789415A1}" type="slidenum">
+            <a:fld id="{07564B93-CB8A-4D9E-80B9-410EA6A7EDBF}" type="slidenum">
               <a:rPr b="0" lang="en" sz="1000" strike="noStrike" u="none">
                 <a:solidFill>
                   <a:schemeClr val="dk2"/>
@@ -18304,7 +18304,7 @@
                 <a:latin typeface="Arial"/>
                 <a:ea typeface="Arial"/>
               </a:rPr>
-              <a:t>&lt;número&gt;</a:t>
+              <a:t>1</a:t>
             </a:fld>
             <a:endParaRPr b="0" lang="es-MX" sz="1000" strike="noStrike" u="none">
               <a:solidFill>
@@ -18860,7 +18860,7 @@
                 <a:spcPct val="100000"/>
               </a:lnSpc>
             </a:pPr>
-            <a:fld id="{2DFACC71-F394-4451-8B6F-A4409BB933BD}" type="datetime5">
+            <a:fld id="{AD2ACED4-5452-4F1C-83FA-776D0DD67CCD}" type="datetime5">
               <a:rPr b="0" i="1" lang="es-MX" sz="1500" strike="noStrike" u="none">
                 <a:solidFill>
                   <a:srgbClr val="000000"/>

</xml_diff>